<commit_message>
Deck: correct conditioning-sweep targets to p10/p50/p90
Slide 24 labelled the three generation arms Tg = 0/100/200 C. The
actual sweep (results/benchmark.md) targets the training-set
percentiles: -10 C (p10), 46 C (p50), 161 C (p90), which produce the
quoted Oracle means of -5.5 / 41.3 / 173.0 C. The +178.5 C shift and
the pass criterion are unchanged.
</commit_message>
<xml_diff>
--- a/docs/PolyGen-RAG_Review.pptx
+++ b/docs/PolyGen-RAG_Review.pptx
@@ -19019,7 +19019,7 @@
                 <a:ea typeface="Arial" pitchFamily="34" charset="-122"/>
                 <a:cs typeface="Arial" pitchFamily="34" charset="-120"/>
               </a:rPr>
-              <a:t>Tg = 0°C</a:t>
+              <a:t>Tg = −10°C</a:t>
             </a:r>
             <a:endParaRPr lang="en-US" sz="1600" dirty="0"/>
           </a:p>
@@ -19167,7 +19167,7 @@
                 <a:ea typeface="Arial" pitchFamily="34" charset="-122"/>
                 <a:cs typeface="Arial" pitchFamily="34" charset="-120"/>
               </a:rPr>
-              <a:t>Tg = 100°C</a:t>
+              <a:t>Tg = 46°C</a:t>
             </a:r>
             <a:endParaRPr lang="en-US" sz="1600" dirty="0"/>
           </a:p>
@@ -19315,7 +19315,7 @@
                 <a:ea typeface="Arial" pitchFamily="34" charset="-122"/>
                 <a:cs typeface="Arial" pitchFamily="34" charset="-120"/>
               </a:rPr>
-              <a:t>Tg = 200°C</a:t>
+              <a:t>Tg = 161°C</a:t>
             </a:r>
             <a:endParaRPr lang="en-US" sz="1600" dirty="0"/>
           </a:p>
@@ -19417,7 +19417,7 @@
                 <a:ea typeface="Arial" pitchFamily="34" charset="-122"/>
                 <a:cs typeface="Arial" pitchFamily="34" charset="-120"/>
               </a:rPr>
-              <a:t>Score every batch with the Oracle</a:t>
+              <a:t>Targets = p10 / p50 / p90 of training Tg;  score every batch with the Oracle</a:t>
             </a:r>
             <a:endParaRPr lang="en-US" sz="1400" dirty="0"/>
           </a:p>

</xml_diff>